<commit_message>
Save before pull (frontend + fixes)
</commit_message>
<xml_diff>
--- a/projet ppt python fr.pptx
+++ b/projet ppt python fr.pptx
@@ -2259,28 +2259,6 @@
             <a:pPr marL="0" indent="0">
               <a:buNone/>
             </a:pPr>
-            <a:r>
-              <a:rPr lang="en-US" sz="1200" b="1" dirty="0">
-                <a:solidFill>
-                  <a:srgbClr val="90CAF9"/>
-                </a:solidFill>
-                <a:latin typeface="Calibri" pitchFamily="34" charset="0"/>
-                <a:ea typeface="Calibri" pitchFamily="34" charset="-122"/>
-                <a:cs typeface="Calibri" pitchFamily="34" charset="-120"/>
-              </a:rPr>
-              <a:t>Encadrante : </a:t>
-            </a:r>
-            <a:r>
-              <a:rPr lang="en-US" sz="1200" dirty="0">
-                <a:solidFill>
-                  <a:srgbClr val="FFFFFF"/>
-                </a:solidFill>
-                <a:latin typeface="Calibri" pitchFamily="34" charset="0"/>
-                <a:ea typeface="Calibri" pitchFamily="34" charset="-122"/>
-                <a:cs typeface="Calibri" pitchFamily="34" charset="-120"/>
-              </a:rPr>
-              <a:t>Prof. Kassid Asmaa</a:t>
-            </a:r>
             <a:endParaRPr lang="en-US" sz="1200" dirty="0"/>
           </a:p>
         </p:txBody>

</xml_diff>